<commit_message>
BRD-11 sign-off set v2.0: Customer Service Agent, Supervisor and Management persona menus in the role matrix (FRS, workbook, guide deck)
</commit_message>
<xml_diff>
--- a/docs/deliverables/out/Drop-0_Setup_and_Data_Migration/BRD-11_User_Access_Maintenance/01_BIBS_GuideDeck_BRD-11_User_Access_Maintenance_v2.0.pptx
+++ b/docs/deliverables/out/Drop-0_Setup_and_Data_Migration/BRD-11_User_Access_Maintenance/01_BIBS_GuideDeck_BRD-11_User_Access_Maintenance_v2.0.pptx
@@ -591,7 +591,7 @@
           <a:lstStyle/>
           <a:p>
             <a:r>
-              <a:t>Each persona sees only the menu entries of its role; the full menu of each persona is in FRS chapter 12 and on the Menu by persona sheet of the workbook. The menus of 37 more personas of the other BRDs are there too, one table and one sheet each.</a:t>
+              <a:t>Each persona sees only the menu entries of its role; the full menu of each persona is in FRS chapter 12 and on the Menu by persona sheet of the workbook. The menus of 40 more personas of the other BRDs are there too, one table and one sheet each.</a:t>
             </a:r>
           </a:p>
         </p:txBody>
@@ -1896,7 +1896,7 @@
           <a:lstStyle/>
           <a:p>
             <a:r>
-              <a:t>The No. column is the numbered marker on the screenshot of the FRS. The drop-down columns accept only the listed values. The Comments log, Meeting minutes and Version history sheets are kept by the project team; the Sign-off certificate is signed at the end.</a:t>
+              <a:t>The No. column is the numbered marker on the screenshot of the FRS, or the column number of a load template. The drop-down columns accept only the listed values. The Comments log, Meeting minutes and Version history sheets are kept by the project team; the Sign-off certificate is signed at the end.</a:t>
             </a:r>
           </a:p>
         </p:txBody>
@@ -7351,7 +7351,7 @@
                 </a:solidFill>
                 <a:latin typeface="Arial"/>
               </a:rPr>
-              <a:t>Full list: FRS chapter 13 per screen, 74 rules on the Business rules sheet and 191 messages in chapter 15 and on the Messages sheet</a:t>
+              <a:t>Full list: FRS chapter 13 per screen, 74 rules on the Business rules sheet and 191 messages in FRS chapter 15 and on the Messages sheet</a:t>
             </a:r>
           </a:p>
         </p:txBody>

</xml_diff>

<commit_message>
BRD-11 User Access Maintenance screenshots retaken in the BDO style-guide presentation on a fresh seed stack: 93 images; FRS, guide deck, sign-off workbook and UX documents 07 to 09 rebuilt at v2.0 with issue 2.2 change CHG-UA-2.2-01; the second-approval shot taken before walkthrough B, Sessions from the user's row menu, the separation-of-duties row menu in the screen specification and fixes for the data access messages
</commit_message>
<xml_diff>
--- a/docs/deliverables/out/Drop-0_Setup_and_Data_Migration/BRD-11_User_Access_Maintenance/01_BIBS_GuideDeck_BRD-11_User_Access_Maintenance_v2.0.pptx
+++ b/docs/deliverables/out/Drop-0_Setup_and_Data_Migration/BRD-11_User_Access_Maintenance/01_BIBS_GuideDeck_BRD-11_User_Access_Maintenance_v2.0.pptx
@@ -10735,8 +10735,8 @@
         </p:blipFill>
         <p:spPr>
           <a:xfrm>
-            <a:off x="6603490" y="1325880"/>
-            <a:ext cx="4669080" cy="1874520"/>
+            <a:off x="6597347" y="1325880"/>
+            <a:ext cx="4681367" cy="1874520"/>
           </a:xfrm>
           <a:prstGeom prst="rect">
             <a:avLst/>
@@ -10799,8 +10799,8 @@
         </p:blipFill>
         <p:spPr>
           <a:xfrm>
-            <a:off x="2279243" y="3566160"/>
-            <a:ext cx="1948840" cy="1874520"/>
+            <a:off x="2683578" y="3566160"/>
+            <a:ext cx="1140171" cy="1874520"/>
           </a:xfrm>
           <a:prstGeom prst="rect">
             <a:avLst/>
@@ -10863,8 +10863,8 @@
         </p:blipFill>
         <p:spPr>
           <a:xfrm>
-            <a:off x="8182072" y="3566160"/>
-            <a:ext cx="1511916" cy="1874520"/>
+            <a:off x="8367945" y="3566160"/>
+            <a:ext cx="1140171" cy="1874520"/>
           </a:xfrm>
           <a:prstGeom prst="rect">
             <a:avLst/>
@@ -11397,7 +11397,7 @@
                 </a:solidFill>
                 <a:latin typeface="Arial"/>
               </a:rPr>
-              <a:t>Full list: FRS chapter 13 per screen, 74 rules on the Business rules sheet and 212 messages in FRS chapter 15 and on the Messages sheet</a:t>
+              <a:t>Full list: FRS chapter 13 per screen, 74 rules on the Business rules sheet and 220 messages in FRS chapter 15 and on the Messages sheet</a:t>
             </a:r>
           </a:p>
         </p:txBody>
@@ -12773,7 +12773,7 @@
                 </a:solidFill>
                 <a:latin typeface="Arial"/>
               </a:rPr>
-              <a:t>Content: 19 screens, 156 fields, 74 business rules, 212 messages</a:t>
+              <a:t>Content: 19 screens, 157 fields, 74 business rules, 220 messages</a:t>
             </a:r>
           </a:p>
           <a:p>

</xml_diff>